<commit_message>
Troca fonte de texto para DM Sans (glifos quebrados com Elza)
Co-Authored-By: Claude Sonnet 5.5 <noreply@anthropic.com>
Claude-Session: https://claude.ai/code/session_0132NY9azEak5pZ8bkBkZQXj
</commit_message>
<xml_diff>
--- a/entrega/Processo_Desenvolvimento_Thunders.pptx
+++ b/entrega/Processo_Desenvolvimento_Thunders.pptx
@@ -1316,9 +1316,9 @@
                 <a:solidFill>
                   <a:srgbClr val="002872"/>
                 </a:solidFill>
-                <a:latin typeface="Elza"/>
-                <a:ea typeface="Elza"/>
-                <a:cs typeface="Elza"/>
+                <a:latin typeface="DM Sans"/>
+                <a:ea typeface="DM Sans"/>
+                <a:cs typeface="DM Sans"/>
               </a:defRPr>
             </a:lvl1pPr>
           </a:lstStyle>
@@ -1389,9 +1389,9 @@
                 <a:solidFill>
                   <a:srgbClr val="002872"/>
                 </a:solidFill>
-                <a:latin typeface="Elza"/>
-                <a:ea typeface="Elza"/>
-                <a:cs typeface="Elza"/>
+                <a:latin typeface="DM Sans"/>
+                <a:ea typeface="DM Sans"/>
+                <a:cs typeface="DM Sans"/>
               </a:defRPr>
             </a:lvl1pPr>
           </a:lstStyle>
@@ -1839,9 +1839,9 @@
                 <a:solidFill>
                   <a:srgbClr val="FFFFFF"/>
                 </a:solidFill>
-                <a:latin typeface="Elza" pitchFamily="34" charset="0"/>
-                <a:ea typeface="Elza" pitchFamily="34" charset="-122"/>
-                <a:cs typeface="Elza" pitchFamily="34" charset="-120"/>
+                <a:latin typeface="DM Sans" pitchFamily="34" charset="0"/>
+                <a:ea typeface="DM Sans" pitchFamily="34" charset="-122"/>
+                <a:cs typeface="DM Sans" pitchFamily="34" charset="-120"/>
               </a:rPr>
               <a:t>Resumo do quadro de processo — Miro</a:t>
             </a:r>
@@ -2086,9 +2086,9 @@
                 <a:solidFill>
                   <a:srgbClr val="002872"/>
                 </a:solidFill>
-                <a:latin typeface="Elza" pitchFamily="34" charset="0"/>
-                <a:ea typeface="Elza" pitchFamily="34" charset="-122"/>
-                <a:cs typeface="Elza" pitchFamily="34" charset="-120"/>
+                <a:latin typeface="DM Sans" pitchFamily="34" charset="0"/>
+                <a:ea typeface="DM Sans" pitchFamily="34" charset="-122"/>
+                <a:cs typeface="DM Sans" pitchFamily="34" charset="-120"/>
               </a:rPr>
               <a:t>Dores, oportunidades, hipóteses e premissas viram o Plano da Iniciativa.</a:t>
             </a:r>
@@ -2230,9 +2230,9 @@
                 <a:solidFill>
                   <a:srgbClr val="002872"/>
                 </a:solidFill>
-                <a:latin typeface="Elza" pitchFamily="34" charset="0"/>
-                <a:ea typeface="Elza" pitchFamily="34" charset="-122"/>
-                <a:cs typeface="Elza" pitchFamily="34" charset="-120"/>
+                <a:latin typeface="DM Sans" pitchFamily="34" charset="0"/>
+                <a:ea typeface="DM Sans" pitchFamily="34" charset="-122"/>
+                <a:cs typeface="DM Sans" pitchFamily="34" charset="-120"/>
               </a:rPr>
               <a:t>Coerência com as dores, alinhamento estratégico e viabilidade técnica.</a:t>
             </a:r>
@@ -2374,9 +2374,9 @@
                 <a:solidFill>
                   <a:srgbClr val="002872"/>
                 </a:solidFill>
-                <a:latin typeface="Elza" pitchFamily="34" charset="0"/>
-                <a:ea typeface="Elza" pitchFamily="34" charset="-122"/>
-                <a:cs typeface="Elza" pitchFamily="34" charset="-120"/>
+                <a:latin typeface="DM Sans" pitchFamily="34" charset="0"/>
+                <a:ea typeface="DM Sans" pitchFamily="34" charset="-122"/>
+                <a:cs typeface="DM Sans" pitchFamily="34" charset="-120"/>
               </a:rPr>
               <a:t>Define, implementa e testa até a entrega.</a:t>
             </a:r>
@@ -2479,9 +2479,9 @@
                 <a:solidFill>
                   <a:srgbClr val="FFFFFF"/>
                 </a:solidFill>
-                <a:latin typeface="Elza" pitchFamily="34" charset="0"/>
-                <a:ea typeface="Elza" pitchFamily="34" charset="-122"/>
-                <a:cs typeface="Elza" pitchFamily="34" charset="-120"/>
+                <a:latin typeface="DM Sans" pitchFamily="34" charset="0"/>
+                <a:ea typeface="DM Sans" pitchFamily="34" charset="-122"/>
+                <a:cs typeface="DM Sans" pitchFamily="34" charset="-120"/>
               </a:rPr>
               <a:t>Iniciativa</a:t>
             </a:r>
@@ -2545,9 +2545,9 @@
                 <a:solidFill>
                   <a:srgbClr val="FFFFFF"/>
                 </a:solidFill>
-                <a:latin typeface="Elza" pitchFamily="34" charset="0"/>
-                <a:ea typeface="Elza" pitchFamily="34" charset="-122"/>
-                <a:cs typeface="Elza" pitchFamily="34" charset="-120"/>
+                <a:latin typeface="DM Sans" pitchFamily="34" charset="0"/>
+                <a:ea typeface="DM Sans" pitchFamily="34" charset="-122"/>
+                <a:cs typeface="DM Sans" pitchFamily="34" charset="-120"/>
               </a:rPr>
               <a:t>Feature</a:t>
             </a:r>
@@ -2611,9 +2611,9 @@
                 <a:solidFill>
                   <a:srgbClr val="FFFFFF"/>
                 </a:solidFill>
-                <a:latin typeface="Elza" pitchFamily="34" charset="0"/>
-                <a:ea typeface="Elza" pitchFamily="34" charset="-122"/>
-                <a:cs typeface="Elza" pitchFamily="34" charset="-120"/>
+                <a:latin typeface="DM Sans" pitchFamily="34" charset="0"/>
+                <a:ea typeface="DM Sans" pitchFamily="34" charset="-122"/>
+                <a:cs typeface="DM Sans" pitchFamily="34" charset="-120"/>
               </a:rPr>
               <a:t>User Stories</a:t>
             </a:r>
@@ -2677,9 +2677,9 @@
                 <a:solidFill>
                   <a:srgbClr val="FFFFFF"/>
                 </a:solidFill>
-                <a:latin typeface="Elza" pitchFamily="34" charset="0"/>
-                <a:ea typeface="Elza" pitchFamily="34" charset="-122"/>
-                <a:cs typeface="Elza" pitchFamily="34" charset="-120"/>
+                <a:latin typeface="DM Sans" pitchFamily="34" charset="0"/>
+                <a:ea typeface="DM Sans" pitchFamily="34" charset="-122"/>
+                <a:cs typeface="DM Sans" pitchFamily="34" charset="-120"/>
               </a:rPr>
               <a:t>Tasks (código)</a:t>
             </a:r>
@@ -2782,9 +2782,9 @@
                 <a:solidFill>
                   <a:srgbClr val="FFFFFF"/>
                 </a:solidFill>
-                <a:latin typeface="Elza" pitchFamily="34" charset="0"/>
-                <a:ea typeface="Elza" pitchFamily="34" charset="-122"/>
-                <a:cs typeface="Elza" pitchFamily="34" charset="-120"/>
+                <a:latin typeface="DM Sans" pitchFamily="34" charset="0"/>
+                <a:ea typeface="DM Sans" pitchFamily="34" charset="-122"/>
+                <a:cs typeface="DM Sans" pitchFamily="34" charset="-120"/>
               </a:rPr>
               <a:t>Propõe melhorias na própria dinâmica (retrospectivas técnicas) e no processo, nos agentes, nas skills e na arquitetura, com os respectivos responsáveis.</a:t>
             </a:r>
@@ -2821,9 +2821,9 @@
                 <a:solidFill>
                   <a:srgbClr val="002872"/>
                 </a:solidFill>
-                <a:latin typeface="Elza" pitchFamily="34" charset="0"/>
-                <a:ea typeface="Elza" pitchFamily="34" charset="-122"/>
-                <a:cs typeface="Elza" pitchFamily="34" charset="-120"/>
+                <a:latin typeface="DM Sans" pitchFamily="34" charset="0"/>
+                <a:ea typeface="DM Sans" pitchFamily="34" charset="-122"/>
+                <a:cs typeface="DM Sans" pitchFamily="34" charset="-120"/>
               </a:rPr>
               <a:t>A gestão guia a célula da imersão até a conclusão da iniciativa.</a:t>
             </a:r>
@@ -2863,9 +2863,9 @@
                 <a:solidFill>
                   <a:srgbClr val="002872"/>
                 </a:solidFill>
-                <a:latin typeface="Elza"/>
-                <a:ea typeface="Elza"/>
-                <a:cs typeface="Elza"/>
+                <a:latin typeface="DM Sans"/>
+                <a:ea typeface="DM Sans"/>
+                <a:cs typeface="DM Sans"/>
               </a:defRPr>
             </a:lvl1pPr>
           </a:lstStyle>
@@ -3165,9 +3165,9 @@
                 <a:solidFill>
                   <a:srgbClr val="002872"/>
                 </a:solidFill>
-                <a:latin typeface="Elza" pitchFamily="34" charset="0"/>
-                <a:ea typeface="Elza" pitchFamily="34" charset="-122"/>
-                <a:cs typeface="Elza" pitchFamily="34" charset="-120"/>
+                <a:latin typeface="DM Sans" pitchFamily="34" charset="0"/>
+                <a:ea typeface="DM Sans" pitchFamily="34" charset="-122"/>
+                <a:cs typeface="DM Sans" pitchFamily="34" charset="-120"/>
               </a:rPr>
               <a:t>A célula recebe o problema a ser tratado</a:t>
             </a:r>
@@ -3334,9 +3334,9 @@
                 <a:solidFill>
                   <a:srgbClr val="002872"/>
                 </a:solidFill>
-                <a:latin typeface="Elza" pitchFamily="34" charset="0"/>
-                <a:ea typeface="Elza" pitchFamily="34" charset="-122"/>
-                <a:cs typeface="Elza" pitchFamily="34" charset="-120"/>
+                <a:latin typeface="DM Sans" pitchFamily="34" charset="0"/>
+                <a:ea typeface="DM Sans" pitchFamily="34" charset="-122"/>
+                <a:cs typeface="DM Sans" pitchFamily="34" charset="-120"/>
               </a:rPr>
               <a:t>Imersão e Concepção da Solução</a:t>
             </a:r>
@@ -3503,9 +3503,9 @@
                 <a:solidFill>
                   <a:srgbClr val="002872"/>
                 </a:solidFill>
-                <a:latin typeface="Elza" pitchFamily="34" charset="0"/>
-                <a:ea typeface="Elza" pitchFamily="34" charset="-122"/>
-                <a:cs typeface="Elza" pitchFamily="34" charset="-120"/>
+                <a:latin typeface="DM Sans" pitchFamily="34" charset="0"/>
+                <a:ea typeface="DM Sans" pitchFamily="34" charset="-122"/>
+                <a:cs typeface="DM Sans" pitchFamily="34" charset="-120"/>
               </a:rPr>
               <a:t>Devemos executar?</a:t>
             </a:r>
@@ -3672,9 +3672,9 @@
                 <a:solidFill>
                   <a:srgbClr val="002872"/>
                 </a:solidFill>
-                <a:latin typeface="Elza" pitchFamily="34" charset="0"/>
-                <a:ea typeface="Elza" pitchFamily="34" charset="-122"/>
-                <a:cs typeface="Elza" pitchFamily="34" charset="-120"/>
+                <a:latin typeface="DM Sans" pitchFamily="34" charset="0"/>
+                <a:ea typeface="DM Sans" pitchFamily="34" charset="-122"/>
+                <a:cs typeface="DM Sans" pitchFamily="34" charset="-120"/>
               </a:rPr>
               <a:t>Define, implementa e testa</a:t>
             </a:r>
@@ -3841,9 +3841,9 @@
                 <a:solidFill>
                   <a:srgbClr val="002872"/>
                 </a:solidFill>
-                <a:latin typeface="Elza" pitchFamily="34" charset="0"/>
-                <a:ea typeface="Elza" pitchFamily="34" charset="-122"/>
-                <a:cs typeface="Elza" pitchFamily="34" charset="-120"/>
+                <a:latin typeface="DM Sans" pitchFamily="34" charset="0"/>
+                <a:ea typeface="DM Sans" pitchFamily="34" charset="-122"/>
+                <a:cs typeface="DM Sans" pitchFamily="34" charset="-120"/>
               </a:rPr>
               <a:t>Publicação, divulgada 24 h antes</a:t>
             </a:r>
@@ -4010,9 +4010,9 @@
                 <a:solidFill>
                   <a:srgbClr val="002872"/>
                 </a:solidFill>
-                <a:latin typeface="Elza" pitchFamily="34" charset="0"/>
-                <a:ea typeface="Elza" pitchFamily="34" charset="-122"/>
-                <a:cs typeface="Elza" pitchFamily="34" charset="-120"/>
+                <a:latin typeface="DM Sans" pitchFamily="34" charset="0"/>
+                <a:ea typeface="DM Sans" pitchFamily="34" charset="-122"/>
+                <a:cs typeface="DM Sans" pitchFamily="34" charset="-120"/>
               </a:rPr>
               <a:t>Itens indispensáveis e checklist de subida</a:t>
             </a:r>
@@ -4179,9 +4179,9 @@
                 <a:solidFill>
                   <a:srgbClr val="002872"/>
                 </a:solidFill>
-                <a:latin typeface="Elza" pitchFamily="34" charset="0"/>
-                <a:ea typeface="Elza" pitchFamily="34" charset="-122"/>
-                <a:cs typeface="Elza" pitchFamily="34" charset="-120"/>
+                <a:latin typeface="DM Sans" pitchFamily="34" charset="0"/>
+                <a:ea typeface="DM Sans" pitchFamily="34" charset="-122"/>
+                <a:cs typeface="DM Sans" pitchFamily="34" charset="-120"/>
               </a:rPr>
               <a:t>Monitoramento de uso e performance</a:t>
             </a:r>
@@ -4348,9 +4348,9 @@
                 <a:solidFill>
                   <a:srgbClr val="002872"/>
                 </a:solidFill>
-                <a:latin typeface="Elza" pitchFamily="34" charset="0"/>
-                <a:ea typeface="Elza" pitchFamily="34" charset="-122"/>
-                <a:cs typeface="Elza" pitchFamily="34" charset="-120"/>
+                <a:latin typeface="DM Sans" pitchFamily="34" charset="0"/>
+                <a:ea typeface="DM Sans" pitchFamily="34" charset="-122"/>
+                <a:cs typeface="DM Sans" pitchFamily="34" charset="-120"/>
               </a:rPr>
               <a:t>Evidências de uso, performance e suporte</a:t>
             </a:r>
@@ -4387,9 +4387,9 @@
                 <a:solidFill>
                   <a:srgbClr val="002872"/>
                 </a:solidFill>
-                <a:latin typeface="Elza" pitchFamily="34" charset="0"/>
-                <a:ea typeface="Elza" pitchFamily="34" charset="-122"/>
-                <a:cs typeface="Elza" pitchFamily="34" charset="-120"/>
+                <a:latin typeface="DM Sans" pitchFamily="34" charset="0"/>
+                <a:ea typeface="DM Sans" pitchFamily="34" charset="-122"/>
+                <a:cs typeface="DM Sans" pitchFamily="34" charset="-120"/>
               </a:rPr>
               <a:t>Gate reprovado volta ao passo anterior (ou replaneja / abandona). Teste não aprovado gera ajustes dentro do tempo de Build.</a:t>
             </a:r>
@@ -4429,9 +4429,9 @@
                 <a:solidFill>
                   <a:srgbClr val="002872"/>
                 </a:solidFill>
-                <a:latin typeface="Elza"/>
-                <a:ea typeface="Elza"/>
-                <a:cs typeface="Elza"/>
+                <a:latin typeface="DM Sans"/>
+                <a:ea typeface="DM Sans"/>
+                <a:cs typeface="DM Sans"/>
               </a:defRPr>
             </a:lvl1pPr>
           </a:lstStyle>
@@ -4647,9 +4647,9 @@
                 <a:solidFill>
                   <a:srgbClr val="002872"/>
                 </a:solidFill>
-                <a:latin typeface="Elza" pitchFamily="34" charset="0"/>
-                <a:ea typeface="Elza" pitchFamily="34" charset="-122"/>
-                <a:cs typeface="Elza" pitchFamily="34" charset="-120"/>
+                <a:latin typeface="DM Sans" pitchFamily="34" charset="0"/>
+                <a:ea typeface="DM Sans" pitchFamily="34" charset="-122"/>
+                <a:cs typeface="DM Sans" pitchFamily="34" charset="-120"/>
               </a:rPr>
               <a:t>O tema que iremos trabalhar</a:t>
             </a:r>
@@ -4668,9 +4668,9 @@
                 <a:solidFill>
                   <a:srgbClr val="002872"/>
                 </a:solidFill>
-                <a:latin typeface="Elza" pitchFamily="34" charset="0"/>
-                <a:ea typeface="Elza" pitchFamily="34" charset="-122"/>
-                <a:cs typeface="Elza" pitchFamily="34" charset="-120"/>
+                <a:latin typeface="DM Sans" pitchFamily="34" charset="0"/>
+                <a:ea typeface="DM Sans" pitchFamily="34" charset="-122"/>
+                <a:cs typeface="DM Sans" pitchFamily="34" charset="-120"/>
               </a:rPr>
               <a:t>A célula recebe o problema a ser tratado</a:t>
             </a:r>
@@ -4689,9 +4689,9 @@
                 <a:solidFill>
                   <a:srgbClr val="002872"/>
                 </a:solidFill>
-                <a:latin typeface="Elza" pitchFamily="34" charset="0"/>
-                <a:ea typeface="Elza" pitchFamily="34" charset="-122"/>
-                <a:cs typeface="Elza" pitchFamily="34" charset="-120"/>
+                <a:latin typeface="DM Sans" pitchFamily="34" charset="0"/>
+                <a:ea typeface="DM Sans" pitchFamily="34" charset="-122"/>
+                <a:cs typeface="DM Sans" pitchFamily="34" charset="-120"/>
               </a:rPr>
               <a:t>Cerimônia: Passagem do Briefing</a:t>
             </a:r>
@@ -4823,9 +4823,9 @@
                 <a:solidFill>
                   <a:srgbClr val="002872"/>
                 </a:solidFill>
-                <a:latin typeface="Elza" pitchFamily="34" charset="0"/>
-                <a:ea typeface="Elza" pitchFamily="34" charset="-122"/>
-                <a:cs typeface="Elza" pitchFamily="34" charset="-120"/>
+                <a:latin typeface="DM Sans" pitchFamily="34" charset="0"/>
+                <a:ea typeface="DM Sans" pitchFamily="34" charset="-122"/>
+                <a:cs typeface="DM Sans" pitchFamily="34" charset="-120"/>
               </a:rPr>
               <a:t>Célula entendendo o tema</a:t>
             </a:r>
@@ -4844,9 +4844,9 @@
                 <a:solidFill>
                   <a:srgbClr val="002872"/>
                 </a:solidFill>
-                <a:latin typeface="Elza" pitchFamily="34" charset="0"/>
-                <a:ea typeface="Elza" pitchFamily="34" charset="-122"/>
-                <a:cs typeface="Elza" pitchFamily="34" charset="-120"/>
+                <a:latin typeface="DM Sans" pitchFamily="34" charset="0"/>
+                <a:ea typeface="DM Sans" pitchFamily="34" charset="-122"/>
+                <a:cs typeface="DM Sans" pitchFamily="34" charset="-120"/>
               </a:rPr>
               <a:t>Entender o suficiente para poder trabalhar no tema</a:t>
             </a:r>
@@ -4865,9 +4865,9 @@
                 <a:solidFill>
                   <a:srgbClr val="002872"/>
                 </a:solidFill>
-                <a:latin typeface="Elza" pitchFamily="34" charset="0"/>
-                <a:ea typeface="Elza" pitchFamily="34" charset="-122"/>
-                <a:cs typeface="Elza" pitchFamily="34" charset="-120"/>
+                <a:latin typeface="DM Sans" pitchFamily="34" charset="0"/>
+                <a:ea typeface="DM Sans" pitchFamily="34" charset="-122"/>
+                <a:cs typeface="DM Sans" pitchFamily="34" charset="-120"/>
               </a:rPr>
               <a:t>Primeiras dores, oportunidades, hipóteses e premissas são levantadas</a:t>
             </a:r>
@@ -4886,9 +4886,9 @@
                 <a:solidFill>
                   <a:srgbClr val="002872"/>
                 </a:solidFill>
-                <a:latin typeface="Elza" pitchFamily="34" charset="0"/>
-                <a:ea typeface="Elza" pitchFamily="34" charset="-122"/>
-                <a:cs typeface="Elza" pitchFamily="34" charset="-120"/>
+                <a:latin typeface="DM Sans" pitchFamily="34" charset="0"/>
+                <a:ea typeface="DM Sans" pitchFamily="34" charset="-122"/>
+                <a:cs typeface="DM Sans" pitchFamily="34" charset="-120"/>
               </a:rPr>
               <a:t>A célula precisa entender um pouco de tudo do que está sendo elaborado</a:t>
             </a:r>
@@ -4952,9 +4952,9 @@
                 <a:solidFill>
                   <a:srgbClr val="09C6FF"/>
                 </a:solidFill>
-                <a:latin typeface="Elza" pitchFamily="34" charset="0"/>
-                <a:ea typeface="Elza" pitchFamily="34" charset="-122"/>
-                <a:cs typeface="Elza" pitchFamily="34" charset="-120"/>
+                <a:latin typeface="DM Sans" pitchFamily="34" charset="0"/>
+                <a:ea typeface="DM Sans" pitchFamily="34" charset="-122"/>
+                <a:cs typeface="DM Sans" pitchFamily="34" charset="-120"/>
               </a:rPr>
               <a:t>Indicador:  </a:t>
             </a:r>
@@ -4966,9 +4966,9 @@
                 <a:solidFill>
                   <a:srgbClr val="FFFFFF"/>
                 </a:solidFill>
-                <a:latin typeface="Elza" pitchFamily="34" charset="0"/>
-                <a:ea typeface="Elza" pitchFamily="34" charset="-122"/>
-                <a:cs typeface="Elza" pitchFamily="34" charset="-120"/>
+                <a:latin typeface="DM Sans" pitchFamily="34" charset="0"/>
+                <a:ea typeface="DM Sans" pitchFamily="34" charset="-122"/>
+                <a:cs typeface="DM Sans" pitchFamily="34" charset="-120"/>
               </a:rPr>
               <a:t>Tempo da Imersão</a:t>
             </a:r>
@@ -5008,9 +5008,9 @@
                 <a:solidFill>
                   <a:srgbClr val="002872"/>
                 </a:solidFill>
-                <a:latin typeface="Elza"/>
-                <a:ea typeface="Elza"/>
-                <a:cs typeface="Elza"/>
+                <a:latin typeface="DM Sans"/>
+                <a:ea typeface="DM Sans"/>
+                <a:cs typeface="DM Sans"/>
               </a:defRPr>
             </a:lvl1pPr>
           </a:lstStyle>
@@ -5222,9 +5222,9 @@
                 <a:solidFill>
                   <a:srgbClr val="00A0D1"/>
                 </a:solidFill>
-                <a:latin typeface="Elza" pitchFamily="34" charset="0"/>
-                <a:ea typeface="Elza" pitchFamily="34" charset="-122"/>
-                <a:cs typeface="Elza" pitchFamily="34" charset="-120"/>
+                <a:latin typeface="DM Sans" pitchFamily="34" charset="0"/>
+                <a:ea typeface="DM Sans" pitchFamily="34" charset="-122"/>
+                <a:cs typeface="DM Sans" pitchFamily="34" charset="-120"/>
               </a:rPr>
               <a:t>O que devemos construir?</a:t>
             </a:r>
@@ -5288,9 +5288,9 @@
                 <a:solidFill>
                   <a:srgbClr val="FFFFFF"/>
                 </a:solidFill>
-                <a:latin typeface="Elza" pitchFamily="34" charset="0"/>
-                <a:ea typeface="Elza" pitchFamily="34" charset="-122"/>
-                <a:cs typeface="Elza" pitchFamily="34" charset="-120"/>
+                <a:latin typeface="DM Sans" pitchFamily="34" charset="0"/>
+                <a:ea typeface="DM Sans" pitchFamily="34" charset="-122"/>
+                <a:cs typeface="DM Sans" pitchFamily="34" charset="-120"/>
               </a:rPr>
               <a:t>Dores / Oportunidades</a:t>
             </a:r>
@@ -5354,9 +5354,9 @@
                 <a:solidFill>
                   <a:srgbClr val="FFFFFF"/>
                 </a:solidFill>
-                <a:latin typeface="Elza" pitchFamily="34" charset="0"/>
-                <a:ea typeface="Elza" pitchFamily="34" charset="-122"/>
-                <a:cs typeface="Elza" pitchFamily="34" charset="-120"/>
+                <a:latin typeface="DM Sans" pitchFamily="34" charset="0"/>
+                <a:ea typeface="DM Sans" pitchFamily="34" charset="-122"/>
+                <a:cs typeface="DM Sans" pitchFamily="34" charset="-120"/>
               </a:rPr>
               <a:t>Hipóteses / Premissas</a:t>
             </a:r>
@@ -5393,9 +5393,9 @@
                 <a:solidFill>
                   <a:srgbClr val="002872"/>
                 </a:solidFill>
-                <a:latin typeface="Elza" pitchFamily="34" charset="0"/>
-                <a:ea typeface="Elza" pitchFamily="34" charset="-122"/>
-                <a:cs typeface="Elza" pitchFamily="34" charset="-120"/>
+                <a:latin typeface="DM Sans" pitchFamily="34" charset="0"/>
+                <a:ea typeface="DM Sans" pitchFamily="34" charset="-122"/>
+                <a:cs typeface="DM Sans" pitchFamily="34" charset="-120"/>
               </a:rPr>
               <a:t>Validar, questionar e entender com o mundo externo; discussão e validação totalmente em conjunto.</a:t>
             </a:r>
@@ -5498,9 +5498,9 @@
                 <a:solidFill>
                   <a:srgbClr val="001845"/>
                 </a:solidFill>
-                <a:latin typeface="Elza" pitchFamily="34" charset="0"/>
-                <a:ea typeface="Elza" pitchFamily="34" charset="-122"/>
-                <a:cs typeface="Elza" pitchFamily="34" charset="-120"/>
+                <a:latin typeface="DM Sans" pitchFamily="34" charset="0"/>
+                <a:ea typeface="DM Sans" pitchFamily="34" charset="-122"/>
+                <a:cs typeface="DM Sans" pitchFamily="34" charset="-120"/>
               </a:rPr>
               <a:t>Negócio</a:t>
             </a:r>
@@ -5564,9 +5564,9 @@
                 <a:solidFill>
                   <a:srgbClr val="001845"/>
                 </a:solidFill>
-                <a:latin typeface="Elza" pitchFamily="34" charset="0"/>
-                <a:ea typeface="Elza" pitchFamily="34" charset="-122"/>
-                <a:cs typeface="Elza" pitchFamily="34" charset="-120"/>
+                <a:latin typeface="DM Sans" pitchFamily="34" charset="0"/>
+                <a:ea typeface="DM Sans" pitchFamily="34" charset="-122"/>
+                <a:cs typeface="DM Sans" pitchFamily="34" charset="-120"/>
               </a:rPr>
               <a:t>Solução</a:t>
             </a:r>
@@ -5630,9 +5630,9 @@
                 <a:solidFill>
                   <a:srgbClr val="001845"/>
                 </a:solidFill>
-                <a:latin typeface="Elza" pitchFamily="34" charset="0"/>
-                <a:ea typeface="Elza" pitchFamily="34" charset="-122"/>
-                <a:cs typeface="Elza" pitchFamily="34" charset="-120"/>
+                <a:latin typeface="DM Sans" pitchFamily="34" charset="0"/>
+                <a:ea typeface="DM Sans" pitchFamily="34" charset="-122"/>
+                <a:cs typeface="DM Sans" pitchFamily="34" charset="-120"/>
               </a:rPr>
               <a:t>Solução arquitetural</a:t>
             </a:r>
@@ -5696,9 +5696,9 @@
                 <a:solidFill>
                   <a:srgbClr val="001845"/>
                 </a:solidFill>
-                <a:latin typeface="Elza" pitchFamily="34" charset="0"/>
-                <a:ea typeface="Elza" pitchFamily="34" charset="-122"/>
-                <a:cs typeface="Elza" pitchFamily="34" charset="-120"/>
+                <a:latin typeface="DM Sans" pitchFamily="34" charset="0"/>
+                <a:ea typeface="DM Sans" pitchFamily="34" charset="-122"/>
+                <a:cs typeface="DM Sans" pitchFamily="34" charset="-120"/>
               </a:rPr>
               <a:t>Governança</a:t>
             </a:r>
@@ -5735,9 +5735,9 @@
                 <a:solidFill>
                   <a:srgbClr val="002872"/>
                 </a:solidFill>
-                <a:latin typeface="Elza" pitchFamily="34" charset="0"/>
-                <a:ea typeface="Elza" pitchFamily="34" charset="-122"/>
-                <a:cs typeface="Elza" pitchFamily="34" charset="-120"/>
+                <a:latin typeface="DM Sans" pitchFamily="34" charset="0"/>
+                <a:ea typeface="DM Sans" pitchFamily="34" charset="-122"/>
+                <a:cs typeface="DM Sans" pitchFamily="34" charset="-120"/>
               </a:rPr>
               <a:t>Output: </a:t>
             </a:r>
@@ -5749,9 +5749,9 @@
                 <a:solidFill>
                   <a:srgbClr val="002872"/>
                 </a:solidFill>
-                <a:latin typeface="Elza" pitchFamily="34" charset="0"/>
-                <a:ea typeface="Elza" pitchFamily="34" charset="-122"/>
-                <a:cs typeface="Elza" pitchFamily="34" charset="-120"/>
+                <a:latin typeface="DM Sans" pitchFamily="34" charset="0"/>
+                <a:ea typeface="DM Sans" pitchFamily="34" charset="-122"/>
+                <a:cs typeface="DM Sans" pitchFamily="34" charset="-120"/>
               </a:rPr>
               <a:t>Plano da Iniciativa e Roadmap priorizado  ·  Indicador: Tempo em Concepção</a:t>
             </a:r>
@@ -5879,9 +5879,9 @@
                 <a:solidFill>
                   <a:srgbClr val="09C6FF"/>
                 </a:solidFill>
-                <a:latin typeface="Elza" pitchFamily="34" charset="0"/>
-                <a:ea typeface="Elza" pitchFamily="34" charset="-122"/>
-                <a:cs typeface="Elza" pitchFamily="34" charset="-120"/>
+                <a:latin typeface="DM Sans" pitchFamily="34" charset="0"/>
+                <a:ea typeface="DM Sans" pitchFamily="34" charset="-122"/>
+                <a:cs typeface="DM Sans" pitchFamily="34" charset="-120"/>
               </a:rPr>
               <a:t>Devemos executar?</a:t>
             </a:r>
@@ -5922,9 +5922,9 @@
                 <a:solidFill>
                   <a:srgbClr val="FFFFFF"/>
                 </a:solidFill>
-                <a:latin typeface="Elza" pitchFamily="34" charset="0"/>
-                <a:ea typeface="Elza" pitchFamily="34" charset="-122"/>
-                <a:cs typeface="Elza" pitchFamily="34" charset="-120"/>
+                <a:latin typeface="DM Sans" pitchFamily="34" charset="0"/>
+                <a:ea typeface="DM Sans" pitchFamily="34" charset="-122"/>
+                <a:cs typeface="DM Sans" pitchFamily="34" charset="-120"/>
               </a:rPr>
               <a:t>Solução coerente com as dores e os temas</a:t>
             </a:r>
@@ -5943,9 +5943,9 @@
                 <a:solidFill>
                   <a:srgbClr val="FFFFFF"/>
                 </a:solidFill>
-                <a:latin typeface="Elza" pitchFamily="34" charset="0"/>
-                <a:ea typeface="Elza" pitchFamily="34" charset="-122"/>
-                <a:cs typeface="Elza" pitchFamily="34" charset="-120"/>
+                <a:latin typeface="DM Sans" pitchFamily="34" charset="0"/>
+                <a:ea typeface="DM Sans" pitchFamily="34" charset="-122"/>
+                <a:cs typeface="DM Sans" pitchFamily="34" charset="-120"/>
               </a:rPr>
               <a:t>Alinhada com a estratégia da empresa</a:t>
             </a:r>
@@ -5964,9 +5964,9 @@
                 <a:solidFill>
                   <a:srgbClr val="FFFFFF"/>
                 </a:solidFill>
-                <a:latin typeface="Elza" pitchFamily="34" charset="0"/>
-                <a:ea typeface="Elza" pitchFamily="34" charset="-122"/>
-                <a:cs typeface="Elza" pitchFamily="34" charset="-120"/>
+                <a:latin typeface="DM Sans" pitchFamily="34" charset="0"/>
+                <a:ea typeface="DM Sans" pitchFamily="34" charset="-122"/>
+                <a:cs typeface="DM Sans" pitchFamily="34" charset="-120"/>
               </a:rPr>
               <a:t>Solução técnica viável (tecnologia, custo)</a:t>
             </a:r>
@@ -6006,9 +6006,9 @@
                 <a:solidFill>
                   <a:srgbClr val="09C6FF"/>
                 </a:solidFill>
-                <a:latin typeface="Elza" pitchFamily="34" charset="0"/>
-                <a:ea typeface="Elza" pitchFamily="34" charset="-122"/>
-                <a:cs typeface="Elza" pitchFamily="34" charset="-120"/>
+                <a:latin typeface="DM Sans" pitchFamily="34" charset="0"/>
+                <a:ea typeface="DM Sans" pitchFamily="34" charset="-122"/>
+                <a:cs typeface="DM Sans" pitchFamily="34" charset="-120"/>
               </a:rPr>
               <a:t>Aprovado: </a:t>
             </a:r>
@@ -6023,9 +6023,9 @@
                 <a:solidFill>
                   <a:srgbClr val="FFFFFF"/>
                 </a:solidFill>
-                <a:latin typeface="Elza" pitchFamily="34" charset="0"/>
-                <a:ea typeface="Elza" pitchFamily="34" charset="-122"/>
-                <a:cs typeface="Elza" pitchFamily="34" charset="-120"/>
+                <a:latin typeface="DM Sans" pitchFamily="34" charset="0"/>
+                <a:ea typeface="DM Sans" pitchFamily="34" charset="-122"/>
+                <a:cs typeface="DM Sans" pitchFamily="34" charset="-120"/>
               </a:rPr>
               <a:t>Build</a:t>
             </a:r>
@@ -6043,9 +6043,9 @@
                 <a:solidFill>
                   <a:srgbClr val="09C6FF"/>
                 </a:solidFill>
-                <a:latin typeface="Elza" pitchFamily="34" charset="0"/>
-                <a:ea typeface="Elza" pitchFamily="34" charset="-122"/>
-                <a:cs typeface="Elza" pitchFamily="34" charset="-120"/>
+                <a:latin typeface="DM Sans" pitchFamily="34" charset="0"/>
+                <a:ea typeface="DM Sans" pitchFamily="34" charset="-122"/>
+                <a:cs typeface="DM Sans" pitchFamily="34" charset="-120"/>
               </a:rPr>
               <a:t>Reprovado: </a:t>
             </a:r>
@@ -6060,9 +6060,9 @@
                 <a:solidFill>
                   <a:srgbClr val="FFFFFF"/>
                 </a:solidFill>
-                <a:latin typeface="Elza" pitchFamily="34" charset="0"/>
-                <a:ea typeface="Elza" pitchFamily="34" charset="-122"/>
-                <a:cs typeface="Elza" pitchFamily="34" charset="-120"/>
+                <a:latin typeface="DM Sans" pitchFamily="34" charset="0"/>
+                <a:ea typeface="DM Sans" pitchFamily="34" charset="-122"/>
+                <a:cs typeface="DM Sans" pitchFamily="34" charset="-120"/>
               </a:rPr>
               <a:t>volta ao passo anterior</a:t>
             </a:r>
@@ -6080,9 +6080,9 @@
                 <a:solidFill>
                   <a:srgbClr val="09C6FF"/>
                 </a:solidFill>
-                <a:latin typeface="Elza" pitchFamily="34" charset="0"/>
-                <a:ea typeface="Elza" pitchFamily="34" charset="-122"/>
-                <a:cs typeface="Elza" pitchFamily="34" charset="-120"/>
+                <a:latin typeface="DM Sans" pitchFamily="34" charset="0"/>
+                <a:ea typeface="DM Sans" pitchFamily="34" charset="-122"/>
+                <a:cs typeface="DM Sans" pitchFamily="34" charset="-120"/>
               </a:rPr>
               <a:t>Replanejamento: </a:t>
             </a:r>
@@ -6097,9 +6097,9 @@
                 <a:solidFill>
                   <a:srgbClr val="FFFFFF"/>
                 </a:solidFill>
-                <a:latin typeface="Elza" pitchFamily="34" charset="0"/>
-                <a:ea typeface="Elza" pitchFamily="34" charset="-122"/>
-                <a:cs typeface="Elza" pitchFamily="34" charset="-120"/>
+                <a:latin typeface="DM Sans" pitchFamily="34" charset="0"/>
+                <a:ea typeface="DM Sans" pitchFamily="34" charset="-122"/>
+                <a:cs typeface="DM Sans" pitchFamily="34" charset="-120"/>
               </a:rPr>
               <a:t>a célula não pode seguir</a:t>
             </a:r>
@@ -6117,9 +6117,9 @@
                 <a:solidFill>
                   <a:srgbClr val="09C6FF"/>
                 </a:solidFill>
-                <a:latin typeface="Elza" pitchFamily="34" charset="0"/>
-                <a:ea typeface="Elza" pitchFamily="34" charset="-122"/>
-                <a:cs typeface="Elza" pitchFamily="34" charset="-120"/>
+                <a:latin typeface="DM Sans" pitchFamily="34" charset="0"/>
+                <a:ea typeface="DM Sans" pitchFamily="34" charset="-122"/>
+                <a:cs typeface="DM Sans" pitchFamily="34" charset="-120"/>
               </a:rPr>
               <a:t>Abandono: </a:t>
             </a:r>
@@ -6134,9 +6134,9 @@
                 <a:solidFill>
                   <a:srgbClr val="FFFFFF"/>
                 </a:solidFill>
-                <a:latin typeface="Elza" pitchFamily="34" charset="0"/>
-                <a:ea typeface="Elza" pitchFamily="34" charset="-122"/>
-                <a:cs typeface="Elza" pitchFamily="34" charset="-120"/>
+                <a:latin typeface="DM Sans" pitchFamily="34" charset="0"/>
+                <a:ea typeface="DM Sans" pitchFamily="34" charset="-122"/>
+                <a:cs typeface="DM Sans" pitchFamily="34" charset="-120"/>
               </a:rPr>
               <a:t>custo ou know-how</a:t>
             </a:r>
@@ -6173,9 +6173,9 @@
                 <a:solidFill>
                   <a:srgbClr val="FFFFFF"/>
                 </a:solidFill>
-                <a:latin typeface="Elza" pitchFamily="34" charset="0"/>
-                <a:ea typeface="Elza" pitchFamily="34" charset="-122"/>
-                <a:cs typeface="Elza" pitchFamily="34" charset="-120"/>
+                <a:latin typeface="DM Sans" pitchFamily="34" charset="0"/>
+                <a:ea typeface="DM Sans" pitchFamily="34" charset="-122"/>
+                <a:cs typeface="DM Sans" pitchFamily="34" charset="-120"/>
               </a:rPr>
               <a:t>Indicadores: taxa de reprovação, iniciativas replanejadas e abandonadas</a:t>
             </a:r>
@@ -6215,9 +6215,9 @@
                 <a:solidFill>
                   <a:srgbClr val="002872"/>
                 </a:solidFill>
-                <a:latin typeface="Elza"/>
-                <a:ea typeface="Elza"/>
-                <a:cs typeface="Elza"/>
+                <a:latin typeface="DM Sans"/>
+                <a:ea typeface="DM Sans"/>
+                <a:cs typeface="DM Sans"/>
               </a:defRPr>
             </a:lvl1pPr>
           </a:lstStyle>
@@ -6468,9 +6468,9 @@
                 <a:solidFill>
                   <a:srgbClr val="002872"/>
                 </a:solidFill>
-                <a:latin typeface="Elza" pitchFamily="34" charset="0"/>
-                <a:ea typeface="Elza" pitchFamily="34" charset="-122"/>
-                <a:cs typeface="Elza" pitchFamily="34" charset="-120"/>
+                <a:latin typeface="DM Sans" pitchFamily="34" charset="0"/>
+                <a:ea typeface="DM Sans" pitchFamily="34" charset="-122"/>
+                <a:cs typeface="DM Sans" pitchFamily="34" charset="-120"/>
               </a:rPr>
               <a:t>Como devemos implementar a feature?</a:t>
             </a:r>
@@ -6485,9 +6485,9 @@
                 <a:solidFill>
                   <a:srgbClr val="002872"/>
                 </a:solidFill>
-                <a:latin typeface="Elza" pitchFamily="34" charset="0"/>
-                <a:ea typeface="Elza" pitchFamily="34" charset="-122"/>
-                <a:cs typeface="Elza" pitchFamily="34" charset="-120"/>
+                <a:latin typeface="DM Sans" pitchFamily="34" charset="0"/>
+                <a:ea typeface="DM Sans" pitchFamily="34" charset="-122"/>
+                <a:cs typeface="DM Sans" pitchFamily="34" charset="-120"/>
               </a:rPr>
               <a:t>SDD · Protótipo</a:t>
             </a:r>
@@ -6654,9 +6654,9 @@
                 <a:solidFill>
                   <a:srgbClr val="002872"/>
                 </a:solidFill>
-                <a:latin typeface="Elza" pitchFamily="34" charset="0"/>
-                <a:ea typeface="Elza" pitchFamily="34" charset="-122"/>
-                <a:cs typeface="Elza" pitchFamily="34" charset="-120"/>
+                <a:latin typeface="DM Sans" pitchFamily="34" charset="0"/>
+                <a:ea typeface="DM Sans" pitchFamily="34" charset="-122"/>
+                <a:cs typeface="DM Sans" pitchFamily="34" charset="-120"/>
               </a:rPr>
               <a:t>Tasks (código) por feature</a:t>
             </a:r>
@@ -6823,9 +6823,9 @@
                 <a:solidFill>
                   <a:srgbClr val="002872"/>
                 </a:solidFill>
-                <a:latin typeface="Elza" pitchFamily="34" charset="0"/>
-                <a:ea typeface="Elza" pitchFamily="34" charset="-122"/>
-                <a:cs typeface="Elza" pitchFamily="34" charset="-120"/>
+                <a:latin typeface="DM Sans" pitchFamily="34" charset="0"/>
+                <a:ea typeface="DM Sans" pitchFamily="34" charset="-122"/>
+                <a:cs typeface="DM Sans" pitchFamily="34" charset="-120"/>
               </a:rPr>
               <a:t>Funcional e usabilidade</a:t>
             </a:r>
@@ -6926,9 +6926,9 @@
                 <a:solidFill>
                   <a:srgbClr val="002872"/>
                 </a:solidFill>
-                <a:latin typeface="Elza" pitchFamily="34" charset="0"/>
-                <a:ea typeface="Elza" pitchFamily="34" charset="-122"/>
-                <a:cs typeface="Elza" pitchFamily="34" charset="-120"/>
+                <a:latin typeface="DM Sans" pitchFamily="34" charset="0"/>
+                <a:ea typeface="DM Sans" pitchFamily="34" charset="-122"/>
+                <a:cs typeface="DM Sans" pitchFamily="34" charset="-120"/>
               </a:rPr>
               <a:t>Sim: sem bugs nem ajustes — segue para o Release</a:t>
             </a:r>
@@ -6992,9 +6992,9 @@
                 <a:solidFill>
                   <a:srgbClr val="09C6FF"/>
                 </a:solidFill>
-                <a:latin typeface="Elza" pitchFamily="34" charset="0"/>
-                <a:ea typeface="Elza" pitchFamily="34" charset="-122"/>
-                <a:cs typeface="Elza" pitchFamily="34" charset="-120"/>
+                <a:latin typeface="DM Sans" pitchFamily="34" charset="0"/>
+                <a:ea typeface="DM Sans" pitchFamily="34" charset="-122"/>
+                <a:cs typeface="DM Sans" pitchFamily="34" charset="-120"/>
               </a:rPr>
               <a:t>Não: </a:t>
             </a:r>
@@ -7006,9 +7006,9 @@
                 <a:solidFill>
                   <a:srgbClr val="FFFFFF"/>
                 </a:solidFill>
-                <a:latin typeface="Elza" pitchFamily="34" charset="0"/>
-                <a:ea typeface="Elza" pitchFamily="34" charset="-122"/>
-                <a:cs typeface="Elza" pitchFamily="34" charset="-120"/>
+                <a:latin typeface="DM Sans" pitchFamily="34" charset="0"/>
+                <a:ea typeface="DM Sans" pitchFamily="34" charset="-122"/>
+                <a:cs typeface="DM Sans" pitchFamily="34" charset="-120"/>
               </a:rPr>
               <a:t>Identificação de ajustes — a célula ajusta e isso entra no tempo de Build.</a:t>
             </a:r>
@@ -7111,9 +7111,9 @@
                 <a:solidFill>
                   <a:srgbClr val="001845"/>
                 </a:solidFill>
-                <a:latin typeface="Elza" pitchFamily="34" charset="0"/>
-                <a:ea typeface="Elza" pitchFamily="34" charset="-122"/>
-                <a:cs typeface="Elza" pitchFamily="34" charset="-120"/>
+                <a:latin typeface="DM Sans" pitchFamily="34" charset="0"/>
+                <a:ea typeface="DM Sans" pitchFamily="34" charset="-122"/>
+                <a:cs typeface="DM Sans" pitchFamily="34" charset="-120"/>
               </a:rPr>
               <a:t>WIP</a:t>
             </a:r>
@@ -7177,9 +7177,9 @@
                 <a:solidFill>
                   <a:srgbClr val="001845"/>
                 </a:solidFill>
-                <a:latin typeface="Elza" pitchFamily="34" charset="0"/>
-                <a:ea typeface="Elza" pitchFamily="34" charset="-122"/>
-                <a:cs typeface="Elza" pitchFamily="34" charset="-120"/>
+                <a:latin typeface="DM Sans" pitchFamily="34" charset="0"/>
+                <a:ea typeface="DM Sans" pitchFamily="34" charset="-122"/>
+                <a:cs typeface="DM Sans" pitchFamily="34" charset="-120"/>
               </a:rPr>
               <a:t>Idade do WIP</a:t>
             </a:r>
@@ -7243,9 +7243,9 @@
                 <a:solidFill>
                   <a:srgbClr val="001845"/>
                 </a:solidFill>
-                <a:latin typeface="Elza" pitchFamily="34" charset="0"/>
-                <a:ea typeface="Elza" pitchFamily="34" charset="-122"/>
-                <a:cs typeface="Elza" pitchFamily="34" charset="-120"/>
+                <a:latin typeface="DM Sans" pitchFamily="34" charset="0"/>
+                <a:ea typeface="DM Sans" pitchFamily="34" charset="-122"/>
+                <a:cs typeface="DM Sans" pitchFamily="34" charset="-120"/>
               </a:rPr>
               <a:t>Lead Time</a:t>
             </a:r>
@@ -7309,9 +7309,9 @@
                 <a:solidFill>
                   <a:srgbClr val="001845"/>
                 </a:solidFill>
-                <a:latin typeface="Elza" pitchFamily="34" charset="0"/>
-                <a:ea typeface="Elza" pitchFamily="34" charset="-122"/>
-                <a:cs typeface="Elza" pitchFamily="34" charset="-120"/>
+                <a:latin typeface="DM Sans" pitchFamily="34" charset="0"/>
+                <a:ea typeface="DM Sans" pitchFamily="34" charset="-122"/>
+                <a:cs typeface="DM Sans" pitchFamily="34" charset="-120"/>
               </a:rPr>
               <a:t>Cycle Time</a:t>
             </a:r>
@@ -7375,9 +7375,9 @@
                 <a:solidFill>
                   <a:srgbClr val="001845"/>
                 </a:solidFill>
-                <a:latin typeface="Elza" pitchFamily="34" charset="0"/>
-                <a:ea typeface="Elza" pitchFamily="34" charset="-122"/>
-                <a:cs typeface="Elza" pitchFamily="34" charset="-120"/>
+                <a:latin typeface="DM Sans" pitchFamily="34" charset="0"/>
+                <a:ea typeface="DM Sans" pitchFamily="34" charset="-122"/>
+                <a:cs typeface="DM Sans" pitchFamily="34" charset="-120"/>
               </a:rPr>
               <a:t>Tempo em Definição</a:t>
             </a:r>
@@ -7441,9 +7441,9 @@
                 <a:solidFill>
                   <a:srgbClr val="001845"/>
                 </a:solidFill>
-                <a:latin typeface="Elza" pitchFamily="34" charset="0"/>
-                <a:ea typeface="Elza" pitchFamily="34" charset="-122"/>
-                <a:cs typeface="Elza" pitchFamily="34" charset="-120"/>
+                <a:latin typeface="DM Sans" pitchFamily="34" charset="0"/>
+                <a:ea typeface="DM Sans" pitchFamily="34" charset="-122"/>
+                <a:cs typeface="DM Sans" pitchFamily="34" charset="-120"/>
               </a:rPr>
               <a:t>Tempo em Teste</a:t>
             </a:r>
@@ -7507,9 +7507,9 @@
                 <a:solidFill>
                   <a:srgbClr val="001845"/>
                 </a:solidFill>
-                <a:latin typeface="Elza" pitchFamily="34" charset="0"/>
-                <a:ea typeface="Elza" pitchFamily="34" charset="-122"/>
-                <a:cs typeface="Elza" pitchFamily="34" charset="-120"/>
+                <a:latin typeface="DM Sans" pitchFamily="34" charset="0"/>
+                <a:ea typeface="DM Sans" pitchFamily="34" charset="-122"/>
+                <a:cs typeface="DM Sans" pitchFamily="34" charset="-120"/>
               </a:rPr>
               <a:t>Tempo em Homologação*</a:t>
             </a:r>
@@ -7573,9 +7573,9 @@
                 <a:solidFill>
                   <a:srgbClr val="001845"/>
                 </a:solidFill>
-                <a:latin typeface="Elza" pitchFamily="34" charset="0"/>
-                <a:ea typeface="Elza" pitchFamily="34" charset="-122"/>
-                <a:cs typeface="Elza" pitchFamily="34" charset="-120"/>
+                <a:latin typeface="DM Sans" pitchFamily="34" charset="0"/>
+                <a:ea typeface="DM Sans" pitchFamily="34" charset="-122"/>
+                <a:cs typeface="DM Sans" pitchFamily="34" charset="-120"/>
               </a:rPr>
               <a:t>Bug em Homologação*</a:t>
             </a:r>
@@ -7615,9 +7615,9 @@
                 <a:solidFill>
                   <a:srgbClr val="002872"/>
                 </a:solidFill>
-                <a:latin typeface="Elza"/>
-                <a:ea typeface="Elza"/>
-                <a:cs typeface="Elza"/>
+                <a:latin typeface="DM Sans"/>
+                <a:ea typeface="DM Sans"/>
+                <a:cs typeface="DM Sans"/>
               </a:defRPr>
             </a:lvl1pPr>
           </a:lstStyle>
@@ -7833,9 +7833,9 @@
                 <a:solidFill>
                   <a:srgbClr val="002872"/>
                 </a:solidFill>
-                <a:latin typeface="Elza" pitchFamily="34" charset="0"/>
-                <a:ea typeface="Elza" pitchFamily="34" charset="-122"/>
-                <a:cs typeface="Elza" pitchFamily="34" charset="-120"/>
+                <a:latin typeface="DM Sans" pitchFamily="34" charset="0"/>
+                <a:ea typeface="DM Sans" pitchFamily="34" charset="-122"/>
+                <a:cs typeface="DM Sans" pitchFamily="34" charset="-120"/>
               </a:rPr>
               <a:t>Divulgada no mínimo 24 h antes da subida</a:t>
             </a:r>
@@ -7854,9 +7854,9 @@
                 <a:solidFill>
                   <a:srgbClr val="002872"/>
                 </a:solidFill>
-                <a:latin typeface="Elza" pitchFamily="34" charset="0"/>
-                <a:ea typeface="Elza" pitchFamily="34" charset="-122"/>
-                <a:cs typeface="Elza" pitchFamily="34" charset="-120"/>
+                <a:latin typeface="DM Sans" pitchFamily="34" charset="0"/>
+                <a:ea typeface="DM Sans" pitchFamily="34" charset="-122"/>
+                <a:cs typeface="DM Sans" pitchFamily="34" charset="-120"/>
               </a:rPr>
               <a:t>Postada no canal do Teams para todos</a:t>
             </a:r>
@@ -7875,9 +7875,9 @@
                 <a:solidFill>
                   <a:srgbClr val="002872"/>
                 </a:solidFill>
-                <a:latin typeface="Elza" pitchFamily="34" charset="0"/>
-                <a:ea typeface="Elza" pitchFamily="34" charset="-122"/>
-                <a:cs typeface="Elza" pitchFamily="34" charset="-120"/>
+                <a:latin typeface="DM Sans" pitchFamily="34" charset="0"/>
+                <a:ea typeface="DM Sans" pitchFamily="34" charset="-122"/>
+                <a:cs typeface="DM Sans" pitchFamily="34" charset="-120"/>
               </a:rPr>
               <a:t>Breve descrição, Demos e Documento Técnico (Requisitos de Subida)</a:t>
             </a:r>
@@ -7896,9 +7896,9 @@
                 <a:solidFill>
                   <a:srgbClr val="002872"/>
                 </a:solidFill>
-                <a:latin typeface="Elza" pitchFamily="34" charset="0"/>
-                <a:ea typeface="Elza" pitchFamily="34" charset="-122"/>
-                <a:cs typeface="Elza" pitchFamily="34" charset="-120"/>
+                <a:latin typeface="DM Sans" pitchFamily="34" charset="0"/>
+                <a:ea typeface="DM Sans" pitchFamily="34" charset="-122"/>
+                <a:cs typeface="DM Sans" pitchFamily="34" charset="-120"/>
               </a:rPr>
               <a:t>A célula decide qual pacote de versões sobe (precisa gerar valor)</a:t>
             </a:r>
@@ -7935,9 +7935,9 @@
                 <a:solidFill>
                   <a:srgbClr val="002872"/>
                 </a:solidFill>
-                <a:latin typeface="Elza" pitchFamily="34" charset="0"/>
-                <a:ea typeface="Elza" pitchFamily="34" charset="-122"/>
-                <a:cs typeface="Elza" pitchFamily="34" charset="-120"/>
+                <a:latin typeface="DM Sans" pitchFamily="34" charset="0"/>
+                <a:ea typeface="DM Sans" pitchFamily="34" charset="-122"/>
+                <a:cs typeface="DM Sans" pitchFamily="34" charset="-120"/>
               </a:rPr>
               <a:t>Indicadores: releases abortadas e concluídas com sucesso, ocorrências em produção, tempo de execução</a:t>
             </a:r>
@@ -8040,9 +8040,9 @@
                 <a:solidFill>
                   <a:srgbClr val="002872"/>
                 </a:solidFill>
-                <a:latin typeface="Elza" pitchFamily="34" charset="0"/>
-                <a:ea typeface="Elza" pitchFamily="34" charset="-122"/>
-                <a:cs typeface="Elza" pitchFamily="34" charset="-120"/>
+                <a:latin typeface="DM Sans" pitchFamily="34" charset="0"/>
+                <a:ea typeface="DM Sans" pitchFamily="34" charset="-122"/>
+                <a:cs typeface="DM Sans" pitchFamily="34" charset="-120"/>
               </a:rPr>
               <a:t>Publica no SharePoint, com informações no Jira: features, regra de negócio, vídeo de utilização</a:t>
             </a:r>
@@ -8145,9 +8145,9 @@
                 <a:solidFill>
                   <a:srgbClr val="002872"/>
                 </a:solidFill>
-                <a:latin typeface="Elza" pitchFamily="34" charset="0"/>
-                <a:ea typeface="Elza" pitchFamily="34" charset="-122"/>
-                <a:cs typeface="Elza" pitchFamily="34" charset="-120"/>
+                <a:latin typeface="DM Sans" pitchFamily="34" charset="0"/>
+                <a:ea typeface="DM Sans" pitchFamily="34" charset="-122"/>
+                <a:cs typeface="DM Sans" pitchFamily="34" charset="-120"/>
               </a:rPr>
               <a:t>Features, script de acompanhamento de uso (quando aplicável), TAG(s) do Mixpanel</a:t>
             </a:r>
@@ -8250,9 +8250,9 @@
                 <a:solidFill>
                   <a:srgbClr val="002872"/>
                 </a:solidFill>
-                <a:latin typeface="Elza" pitchFamily="34" charset="0"/>
-                <a:ea typeface="Elza" pitchFamily="34" charset="-122"/>
-                <a:cs typeface="Elza" pitchFamily="34" charset="-120"/>
+                <a:latin typeface="DM Sans" pitchFamily="34" charset="0"/>
+                <a:ea typeface="DM Sans" pitchFamily="34" charset="-122"/>
+                <a:cs typeface="DM Sans" pitchFamily="34" charset="-120"/>
               </a:rPr>
               <a:t>Features, tamanho de campos, índices, slow queries e plano de execução</a:t>
             </a:r>
@@ -8355,9 +8355,9 @@
                 <a:solidFill>
                   <a:srgbClr val="FFFFFF"/>
                 </a:solidFill>
-                <a:latin typeface="Elza" pitchFamily="34" charset="0"/>
-                <a:ea typeface="Elza" pitchFamily="34" charset="-122"/>
-                <a:cs typeface="Elza" pitchFamily="34" charset="-120"/>
+                <a:latin typeface="DM Sans" pitchFamily="34" charset="0"/>
+                <a:ea typeface="DM Sans" pitchFamily="34" charset="-122"/>
+                <a:cs typeface="DM Sans" pitchFamily="34" charset="-120"/>
               </a:rPr>
               <a:t>Microsserviços (PRs), feature flag, tenants e scripts; informações centralizadas na feature do Jira</a:t>
             </a:r>
@@ -8397,9 +8397,9 @@
                 <a:solidFill>
                   <a:srgbClr val="002872"/>
                 </a:solidFill>
-                <a:latin typeface="Elza"/>
-                <a:ea typeface="Elza"/>
-                <a:cs typeface="Elza"/>
+                <a:latin typeface="DM Sans"/>
+                <a:ea typeface="DM Sans"/>
+                <a:cs typeface="DM Sans"/>
               </a:defRPr>
             </a:lvl1pPr>
           </a:lstStyle>
@@ -8615,9 +8615,9 @@
                 <a:solidFill>
                   <a:srgbClr val="002872"/>
                 </a:solidFill>
-                <a:latin typeface="Elza" pitchFamily="34" charset="0"/>
-                <a:ea typeface="Elza" pitchFamily="34" charset="-122"/>
-                <a:cs typeface="Elza" pitchFamily="34" charset="-120"/>
+                <a:latin typeface="DM Sans" pitchFamily="34" charset="0"/>
+                <a:ea typeface="DM Sans" pitchFamily="34" charset="-122"/>
+                <a:cs typeface="DM Sans" pitchFamily="34" charset="-120"/>
               </a:rPr>
               <a:t>Métricas de uso e de performance (Grafana)</a:t>
             </a:r>
@@ -8636,9 +8636,9 @@
                 <a:solidFill>
                   <a:srgbClr val="002872"/>
                 </a:solidFill>
-                <a:latin typeface="Elza" pitchFamily="34" charset="0"/>
-                <a:ea typeface="Elza" pitchFamily="34" charset="-122"/>
-                <a:cs typeface="Elza" pitchFamily="34" charset="-120"/>
+                <a:latin typeface="DM Sans" pitchFamily="34" charset="0"/>
+                <a:ea typeface="DM Sans" pitchFamily="34" charset="-122"/>
+                <a:cs typeface="DM Sans" pitchFamily="34" charset="-120"/>
               </a:rPr>
               <a:t>Suporte (tickets) e fila do Rabbit (processamento, erro, DLQ)</a:t>
             </a:r>
@@ -8657,9 +8657,9 @@
                 <a:solidFill>
                   <a:srgbClr val="002872"/>
                 </a:solidFill>
-                <a:latin typeface="Elza" pitchFamily="34" charset="0"/>
-                <a:ea typeface="Elza" pitchFamily="34" charset="-122"/>
-                <a:cs typeface="Elza" pitchFamily="34" charset="-120"/>
+                <a:latin typeface="DM Sans" pitchFamily="34" charset="0"/>
+                <a:ea typeface="DM Sans" pitchFamily="34" charset="-122"/>
+                <a:cs typeface="DM Sans" pitchFamily="34" charset="-120"/>
               </a:rPr>
               <a:t>Comparações: hoje × ontem, × última semana, × último mês (relativo)</a:t>
             </a:r>
@@ -8766,9 +8766,9 @@
                 <a:solidFill>
                   <a:srgbClr val="002872"/>
                 </a:solidFill>
-                <a:latin typeface="Elza" pitchFamily="34" charset="0"/>
-                <a:ea typeface="Elza" pitchFamily="34" charset="-122"/>
-                <a:cs typeface="Elza" pitchFamily="34" charset="-120"/>
+                <a:latin typeface="DM Sans" pitchFamily="34" charset="0"/>
+                <a:ea typeface="DM Sans" pitchFamily="34" charset="-122"/>
+                <a:cs typeface="DM Sans" pitchFamily="34" charset="-120"/>
               </a:rPr>
               <a:t>Evidências de uso e de performance (Grafana)</a:t>
             </a:r>
@@ -8787,9 +8787,9 @@
                 <a:solidFill>
                   <a:srgbClr val="002872"/>
                 </a:solidFill>
-                <a:latin typeface="Elza" pitchFamily="34" charset="0"/>
-                <a:ea typeface="Elza" pitchFamily="34" charset="-122"/>
-                <a:cs typeface="Elza" pitchFamily="34" charset="-120"/>
+                <a:latin typeface="DM Sans" pitchFamily="34" charset="0"/>
+                <a:ea typeface="DM Sans" pitchFamily="34" charset="-122"/>
+                <a:cs typeface="DM Sans" pitchFamily="34" charset="-120"/>
               </a:rPr>
               <a:t>Evidências de suporte (tickets) e da fila do Rabbit</a:t>
             </a:r>
@@ -8808,9 +8808,9 @@
                 <a:solidFill>
                   <a:srgbClr val="002872"/>
                 </a:solidFill>
-                <a:latin typeface="Elza" pitchFamily="34" charset="0"/>
-                <a:ea typeface="Elza" pitchFamily="34" charset="-122"/>
-                <a:cs typeface="Elza" pitchFamily="34" charset="-120"/>
+                <a:latin typeface="DM Sans" pitchFamily="34" charset="0"/>
+                <a:ea typeface="DM Sans" pitchFamily="34" charset="-122"/>
+                <a:cs typeface="DM Sans" pitchFamily="34" charset="-120"/>
               </a:rPr>
               <a:t>Garantia de 90 dias, sempre sem custo ao cliente</a:t>
             </a:r>
@@ -8913,9 +8913,9 @@
                 <a:solidFill>
                   <a:srgbClr val="FFFFFF"/>
                 </a:solidFill>
-                <a:latin typeface="Elza" pitchFamily="34" charset="0"/>
-                <a:ea typeface="Elza" pitchFamily="34" charset="-122"/>
-                <a:cs typeface="Elza" pitchFamily="34" charset="-120"/>
+                <a:latin typeface="DM Sans" pitchFamily="34" charset="0"/>
+                <a:ea typeface="DM Sans" pitchFamily="34" charset="-122"/>
+                <a:cs typeface="DM Sans" pitchFamily="34" charset="-120"/>
               </a:rPr>
               <a:t>Deployment Frequency (mensal)</a:t>
             </a:r>
@@ -8979,9 +8979,9 @@
                 <a:solidFill>
                   <a:srgbClr val="FFFFFF"/>
                 </a:solidFill>
-                <a:latin typeface="Elza" pitchFamily="34" charset="0"/>
-                <a:ea typeface="Elza" pitchFamily="34" charset="-122"/>
-                <a:cs typeface="Elza" pitchFamily="34" charset="-120"/>
+                <a:latin typeface="DM Sans" pitchFamily="34" charset="0"/>
+                <a:ea typeface="DM Sans" pitchFamily="34" charset="-122"/>
+                <a:cs typeface="DM Sans" pitchFamily="34" charset="-120"/>
               </a:rPr>
               <a:t>Change Failure Rate</a:t>
             </a:r>
@@ -9045,9 +9045,9 @@
                 <a:solidFill>
                   <a:srgbClr val="FFFFFF"/>
                 </a:solidFill>
-                <a:latin typeface="Elza" pitchFamily="34" charset="0"/>
-                <a:ea typeface="Elza" pitchFamily="34" charset="-122"/>
-                <a:cs typeface="Elza" pitchFamily="34" charset="-120"/>
+                <a:latin typeface="DM Sans" pitchFamily="34" charset="0"/>
+                <a:ea typeface="DM Sans" pitchFamily="34" charset="-122"/>
+                <a:cs typeface="DM Sans" pitchFamily="34" charset="-120"/>
               </a:rPr>
               <a:t>Tempo gasto nas correções</a:t>
             </a:r>
@@ -9111,9 +9111,9 @@
                 <a:solidFill>
                   <a:srgbClr val="FFFFFF"/>
                 </a:solidFill>
-                <a:latin typeface="Elza" pitchFamily="34" charset="0"/>
-                <a:ea typeface="Elza" pitchFamily="34" charset="-122"/>
-                <a:cs typeface="Elza" pitchFamily="34" charset="-120"/>
+                <a:latin typeface="DM Sans" pitchFamily="34" charset="0"/>
+                <a:ea typeface="DM Sans" pitchFamily="34" charset="-122"/>
+                <a:cs typeface="DM Sans" pitchFamily="34" charset="-120"/>
               </a:rPr>
               <a:t>Previsto × Real (utilização mensal)</a:t>
             </a:r>
@@ -9177,9 +9177,9 @@
                 <a:solidFill>
                   <a:srgbClr val="FFFFFF"/>
                 </a:solidFill>
-                <a:latin typeface="Elza" pitchFamily="34" charset="0"/>
-                <a:ea typeface="Elza" pitchFamily="34" charset="-122"/>
-                <a:cs typeface="Elza" pitchFamily="34" charset="-120"/>
+                <a:latin typeface="DM Sans" pitchFamily="34" charset="0"/>
+                <a:ea typeface="DM Sans" pitchFamily="34" charset="-122"/>
+                <a:cs typeface="DM Sans" pitchFamily="34" charset="-120"/>
               </a:rPr>
               <a:t>Chamados em produção</a:t>
             </a:r>
@@ -9243,9 +9243,9 @@
                 <a:solidFill>
                   <a:srgbClr val="FFFFFF"/>
                 </a:solidFill>
-                <a:latin typeface="Elza" pitchFamily="34" charset="0"/>
-                <a:ea typeface="Elza" pitchFamily="34" charset="-122"/>
-                <a:cs typeface="Elza" pitchFamily="34" charset="-120"/>
+                <a:latin typeface="DM Sans" pitchFamily="34" charset="0"/>
+                <a:ea typeface="DM Sans" pitchFamily="34" charset="-122"/>
+                <a:cs typeface="DM Sans" pitchFamily="34" charset="-120"/>
               </a:rPr>
               <a:t>Aderência em produção</a:t>
             </a:r>
@@ -9285,9 +9285,9 @@
                 <a:solidFill>
                   <a:srgbClr val="002872"/>
                 </a:solidFill>
-                <a:latin typeface="Elza"/>
-                <a:ea typeface="Elza"/>
-                <a:cs typeface="Elza"/>
+                <a:latin typeface="DM Sans"/>
+                <a:ea typeface="DM Sans"/>
+                <a:cs typeface="DM Sans"/>
               </a:defRPr>
             </a:lvl1pPr>
           </a:lstStyle>
@@ -9404,7 +9404,7 @@
         <a:font script="Tfng" typeface="Ebrima"/>
       </a:majorFont>
       <a:minorFont>
-        <a:latin typeface="Elza"/>
+        <a:latin typeface="DM Sans"/>
         <a:ea typeface=""/>
         <a:cs typeface=""/>
         <a:font script="Jpan" typeface="游ゴシック"/>

</xml_diff>